<commit_message>
Evolution code maître des oyas: - Gestion des tailles d'oyas (meme principe que la config des esclaves presents) - Memorisation config esclaves - Mise à jour config possible par mqtt et par terminal
Site Web et serveur:
- Affichage des gros oyas
- Amélioration affichage quand le réseau ne répond pas (pas pertinent d'avoir le récap des niveaux bas pour ces esclaves out)
</commit_message>
<xml_diff>
--- a/cuves/docs/montages.pptx
+++ b/cuves/docs/montages.pptx
@@ -264,7 +264,7 @@
           <a:p>
             <a:fld id="{F2DD6B95-511F-4BDA-9CF0-98EE77A1CEFE}" type="datetimeFigureOut">
               <a:rPr lang="fr-FR" smtClean="0"/>
-              <a:t>18/04/2026</a:t>
+              <a:t>20/04/2026</a:t>
             </a:fld>
             <a:endParaRPr lang="fr-FR"/>
           </a:p>
@@ -462,7 +462,7 @@
           <a:p>
             <a:fld id="{F2DD6B95-511F-4BDA-9CF0-98EE77A1CEFE}" type="datetimeFigureOut">
               <a:rPr lang="fr-FR" smtClean="0"/>
-              <a:t>18/04/2026</a:t>
+              <a:t>20/04/2026</a:t>
             </a:fld>
             <a:endParaRPr lang="fr-FR"/>
           </a:p>
@@ -670,7 +670,7 @@
           <a:p>
             <a:fld id="{F2DD6B95-511F-4BDA-9CF0-98EE77A1CEFE}" type="datetimeFigureOut">
               <a:rPr lang="fr-FR" smtClean="0"/>
-              <a:t>18/04/2026</a:t>
+              <a:t>20/04/2026</a:t>
             </a:fld>
             <a:endParaRPr lang="fr-FR"/>
           </a:p>
@@ -868,7 +868,7 @@
           <a:p>
             <a:fld id="{F2DD6B95-511F-4BDA-9CF0-98EE77A1CEFE}" type="datetimeFigureOut">
               <a:rPr lang="fr-FR" smtClean="0"/>
-              <a:t>18/04/2026</a:t>
+              <a:t>20/04/2026</a:t>
             </a:fld>
             <a:endParaRPr lang="fr-FR"/>
           </a:p>
@@ -1143,7 +1143,7 @@
           <a:p>
             <a:fld id="{F2DD6B95-511F-4BDA-9CF0-98EE77A1CEFE}" type="datetimeFigureOut">
               <a:rPr lang="fr-FR" smtClean="0"/>
-              <a:t>18/04/2026</a:t>
+              <a:t>20/04/2026</a:t>
             </a:fld>
             <a:endParaRPr lang="fr-FR"/>
           </a:p>
@@ -1408,7 +1408,7 @@
           <a:p>
             <a:fld id="{F2DD6B95-511F-4BDA-9CF0-98EE77A1CEFE}" type="datetimeFigureOut">
               <a:rPr lang="fr-FR" smtClean="0"/>
-              <a:t>18/04/2026</a:t>
+              <a:t>20/04/2026</a:t>
             </a:fld>
             <a:endParaRPr lang="fr-FR"/>
           </a:p>
@@ -1820,7 +1820,7 @@
           <a:p>
             <a:fld id="{F2DD6B95-511F-4BDA-9CF0-98EE77A1CEFE}" type="datetimeFigureOut">
               <a:rPr lang="fr-FR" smtClean="0"/>
-              <a:t>18/04/2026</a:t>
+              <a:t>20/04/2026</a:t>
             </a:fld>
             <a:endParaRPr lang="fr-FR"/>
           </a:p>
@@ -1961,7 +1961,7 @@
           <a:p>
             <a:fld id="{F2DD6B95-511F-4BDA-9CF0-98EE77A1CEFE}" type="datetimeFigureOut">
               <a:rPr lang="fr-FR" smtClean="0"/>
-              <a:t>18/04/2026</a:t>
+              <a:t>20/04/2026</a:t>
             </a:fld>
             <a:endParaRPr lang="fr-FR"/>
           </a:p>
@@ -2074,7 +2074,7 @@
           <a:p>
             <a:fld id="{F2DD6B95-511F-4BDA-9CF0-98EE77A1CEFE}" type="datetimeFigureOut">
               <a:rPr lang="fr-FR" smtClean="0"/>
-              <a:t>18/04/2026</a:t>
+              <a:t>20/04/2026</a:t>
             </a:fld>
             <a:endParaRPr lang="fr-FR"/>
           </a:p>
@@ -2385,7 +2385,7 @@
           <a:p>
             <a:fld id="{F2DD6B95-511F-4BDA-9CF0-98EE77A1CEFE}" type="datetimeFigureOut">
               <a:rPr lang="fr-FR" smtClean="0"/>
-              <a:t>18/04/2026</a:t>
+              <a:t>20/04/2026</a:t>
             </a:fld>
             <a:endParaRPr lang="fr-FR"/>
           </a:p>
@@ -2673,7 +2673,7 @@
           <a:p>
             <a:fld id="{F2DD6B95-511F-4BDA-9CF0-98EE77A1CEFE}" type="datetimeFigureOut">
               <a:rPr lang="fr-FR" smtClean="0"/>
-              <a:t>18/04/2026</a:t>
+              <a:t>20/04/2026</a:t>
             </a:fld>
             <a:endParaRPr lang="fr-FR"/>
           </a:p>
@@ -2914,7 +2914,7 @@
           <a:p>
             <a:fld id="{F2DD6B95-511F-4BDA-9CF0-98EE77A1CEFE}" type="datetimeFigureOut">
               <a:rPr lang="fr-FR" smtClean="0"/>
-              <a:t>18/04/2026</a:t>
+              <a:t>20/04/2026</a:t>
             </a:fld>
             <a:endParaRPr lang="fr-FR"/>
           </a:p>
@@ -3453,10 +3453,10 @@
       </p:grpSpPr>
       <p:pic>
         <p:nvPicPr>
-          <p:cNvPr id="4" name="Image 3">
-            <a:extLst>
-              <a:ext uri="{FF2B5EF4-FFF2-40B4-BE49-F238E27FC236}">
-                <a16:creationId xmlns:a16="http://schemas.microsoft.com/office/drawing/2014/main" id="{DB59B971-644F-2539-FBDF-C0E4CD981407}"/>
+          <p:cNvPr id="44" name="Image 43">
+            <a:extLst>
+              <a:ext uri="{FF2B5EF4-FFF2-40B4-BE49-F238E27FC236}">
+                <a16:creationId xmlns:a16="http://schemas.microsoft.com/office/drawing/2014/main" id="{80E9AF5C-46E0-6B37-DC2C-4030E7055F4F}"/>
               </a:ext>
             </a:extLst>
           </p:cNvPr>
@@ -3473,8 +3473,38 @@
         </p:blipFill>
         <p:spPr>
           <a:xfrm>
-            <a:off x="537392" y="426695"/>
-            <a:ext cx="2038635" cy="2191056"/>
+            <a:off x="3538672" y="3732808"/>
+            <a:ext cx="2273121" cy="1997591"/>
+          </a:xfrm>
+          <a:prstGeom prst="rect">
+            <a:avLst/>
+          </a:prstGeom>
+        </p:spPr>
+      </p:pic>
+      <p:pic>
+        <p:nvPicPr>
+          <p:cNvPr id="19" name="Image 18">
+            <a:extLst>
+              <a:ext uri="{FF2B5EF4-FFF2-40B4-BE49-F238E27FC236}">
+                <a16:creationId xmlns:a16="http://schemas.microsoft.com/office/drawing/2014/main" id="{EEC18BE8-3A1C-5CB5-366B-A8B578E0421D}"/>
+              </a:ext>
+            </a:extLst>
+          </p:cNvPr>
+          <p:cNvPicPr>
+            <a:picLocks noChangeAspect="1"/>
+          </p:cNvPicPr>
+          <p:nvPr/>
+        </p:nvPicPr>
+        <p:blipFill>
+          <a:blip r:embed="rId3"/>
+          <a:stretch>
+            <a:fillRect/>
+          </a:stretch>
+        </p:blipFill>
+        <p:spPr>
+          <a:xfrm>
+            <a:off x="1248433" y="489592"/>
+            <a:ext cx="1902355" cy="1622597"/>
           </a:xfrm>
           <a:prstGeom prst="rect">
             <a:avLst/>
@@ -3495,10 +3525,10 @@
         </p:nvGrpSpPr>
         <p:grpSpPr>
           <a:xfrm>
-            <a:off x="2241755" y="1877858"/>
-            <a:ext cx="2980378" cy="781908"/>
-            <a:chOff x="4572000" y="2290813"/>
-            <a:chExt cx="2980378" cy="781908"/>
+            <a:off x="2199610" y="1945374"/>
+            <a:ext cx="2706913" cy="1377004"/>
+            <a:chOff x="4630620" y="2236833"/>
+            <a:chExt cx="2706913" cy="1377004"/>
           </a:xfrm>
         </p:grpSpPr>
         <p:cxnSp>
@@ -3517,8 +3547,8 @@
           </p:nvCxnSpPr>
           <p:spPr>
             <a:xfrm flipH="1" flipV="1">
-              <a:off x="4572000" y="2290813"/>
-              <a:ext cx="1258432" cy="597242"/>
+              <a:off x="4630620" y="2236833"/>
+              <a:ext cx="1079871" cy="1038488"/>
             </a:xfrm>
             <a:prstGeom prst="straightConnector1">
               <a:avLst/>
@@ -3556,7 +3586,7 @@
           </p:nvSpPr>
           <p:spPr>
             <a:xfrm>
-              <a:off x="5830432" y="2703389"/>
+              <a:off x="5615587" y="3244505"/>
               <a:ext cx="1721946" cy="369332"/>
             </a:xfrm>
             <a:prstGeom prst="rect">
@@ -3600,10 +3630,10 @@
         </p:nvGrpSpPr>
         <p:grpSpPr>
           <a:xfrm>
-            <a:off x="1848481" y="1928176"/>
-            <a:ext cx="1512714" cy="840149"/>
-            <a:chOff x="4572000" y="2290813"/>
-            <a:chExt cx="1512714" cy="840149"/>
+            <a:off x="1761006" y="4776737"/>
+            <a:ext cx="2344547" cy="369332"/>
+            <a:chOff x="4239495" y="1474559"/>
+            <a:chExt cx="2344547" cy="369332"/>
           </a:xfrm>
         </p:grpSpPr>
         <p:cxnSp>
@@ -3621,9 +3651,9 @@
             <p:nvPr/>
           </p:nvCxnSpPr>
           <p:spPr>
-            <a:xfrm flipH="1" flipV="1">
-              <a:off x="4572000" y="2290813"/>
-              <a:ext cx="526328" cy="573312"/>
+            <a:xfrm>
+              <a:off x="5335946" y="1662104"/>
+              <a:ext cx="1248096" cy="21151"/>
             </a:xfrm>
             <a:prstGeom prst="straightConnector1">
               <a:avLst/>
@@ -3661,7 +3691,7 @@
           </p:nvSpPr>
           <p:spPr>
             <a:xfrm>
-              <a:off x="5056869" y="2761630"/>
+              <a:off x="4239495" y="1474559"/>
               <a:ext cx="1027845" cy="369332"/>
             </a:xfrm>
             <a:prstGeom prst="rect">
@@ -3697,10 +3727,10 @@
         </p:nvGrpSpPr>
         <p:grpSpPr>
           <a:xfrm>
-            <a:off x="1583679" y="2054711"/>
-            <a:ext cx="1981392" cy="1181442"/>
-            <a:chOff x="4375363" y="2021628"/>
-            <a:chExt cx="1981392" cy="1181442"/>
+            <a:off x="1023759" y="1817745"/>
+            <a:ext cx="1253869" cy="1734636"/>
+            <a:chOff x="5746223" y="570764"/>
+            <a:chExt cx="1253869" cy="1734636"/>
           </a:xfrm>
         </p:grpSpPr>
         <p:cxnSp>
@@ -3718,9 +3748,9 @@
             <p:nvPr/>
           </p:nvCxnSpPr>
           <p:spPr>
-            <a:xfrm flipH="1" flipV="1">
-              <a:off x="4375363" y="2021628"/>
-              <a:ext cx="749671" cy="935460"/>
+            <a:xfrm flipV="1">
+              <a:off x="6373158" y="570764"/>
+              <a:ext cx="73711" cy="1282849"/>
             </a:xfrm>
             <a:prstGeom prst="straightConnector1">
               <a:avLst/>
@@ -3758,7 +3788,7 @@
           </p:nvSpPr>
           <p:spPr>
             <a:xfrm>
-              <a:off x="5102886" y="2833738"/>
+              <a:off x="5746223" y="1936068"/>
               <a:ext cx="1253869" cy="369332"/>
             </a:xfrm>
             <a:prstGeom prst="rect">
@@ -3794,10 +3824,10 @@
         </p:nvGrpSpPr>
         <p:grpSpPr>
           <a:xfrm>
-            <a:off x="1288460" y="2232898"/>
-            <a:ext cx="1892933" cy="1389754"/>
-            <a:chOff x="4375363" y="2021628"/>
-            <a:chExt cx="1892933" cy="1389754"/>
+            <a:off x="0" y="1764314"/>
+            <a:ext cx="1504071" cy="1336280"/>
+            <a:chOff x="4543891" y="-73388"/>
+            <a:chExt cx="1504071" cy="1336280"/>
           </a:xfrm>
         </p:grpSpPr>
         <p:cxnSp>
@@ -3815,9 +3845,9 @@
             <p:nvPr/>
           </p:nvCxnSpPr>
           <p:spPr>
-            <a:xfrm flipH="1" flipV="1">
-              <a:off x="4375363" y="2021628"/>
-              <a:ext cx="812123" cy="1020422"/>
+            <a:xfrm flipV="1">
+              <a:off x="5413607" y="-73388"/>
+              <a:ext cx="634355" cy="915656"/>
             </a:xfrm>
             <a:prstGeom prst="straightConnector1">
               <a:avLst/>
@@ -3855,7 +3885,7 @@
           </p:nvSpPr>
           <p:spPr>
             <a:xfrm>
-              <a:off x="5125034" y="3042050"/>
+              <a:off x="4543891" y="893560"/>
               <a:ext cx="1143262" cy="369332"/>
             </a:xfrm>
             <a:prstGeom prst="rect">
@@ -3892,7 +3922,7 @@
           <p:nvPr/>
         </p:nvPicPr>
         <p:blipFill>
-          <a:blip r:embed="rId3"/>
+          <a:blip r:embed="rId4"/>
           <a:stretch>
             <a:fillRect/>
           </a:stretch>
@@ -3921,7 +3951,7 @@
         </p:nvSpPr>
         <p:spPr>
           <a:xfrm>
-            <a:off x="700248" y="192781"/>
+            <a:off x="1653356" y="68800"/>
             <a:ext cx="1674561" cy="369332"/>
           </a:xfrm>
           <a:prstGeom prst="rect">
@@ -3957,7 +3987,7 @@
           <p:nvPr/>
         </p:nvPicPr>
         <p:blipFill>
-          <a:blip r:embed="rId4"/>
+          <a:blip r:embed="rId5"/>
           <a:stretch>
             <a:fillRect/>
           </a:stretch>
@@ -4047,7 +4077,7 @@
           <p:nvPr/>
         </p:nvPicPr>
         <p:blipFill>
-          <a:blip r:embed="rId5"/>
+          <a:blip r:embed="rId6"/>
           <a:stretch>
             <a:fillRect/>
           </a:stretch>
@@ -4113,6 +4143,437 @@
             <a:r>
               <a:rPr lang="fr-FR" dirty="0"/>
               <a:t>Noir: PMP</a:t>
+            </a:r>
+          </a:p>
+        </p:txBody>
+      </p:sp>
+      <p:grpSp>
+        <p:nvGrpSpPr>
+          <p:cNvPr id="33" name="Groupe 32">
+            <a:extLst>
+              <a:ext uri="{FF2B5EF4-FFF2-40B4-BE49-F238E27FC236}">
+                <a16:creationId xmlns:a16="http://schemas.microsoft.com/office/drawing/2014/main" id="{0827961A-CD1D-8323-2914-D5B1F6337225}"/>
+              </a:ext>
+            </a:extLst>
+          </p:cNvPr>
+          <p:cNvGrpSpPr/>
+          <p:nvPr/>
+        </p:nvGrpSpPr>
+        <p:grpSpPr>
+          <a:xfrm>
+            <a:off x="1045306" y="4297026"/>
+            <a:ext cx="2940457" cy="512718"/>
+            <a:chOff x="4867466" y="1872748"/>
+            <a:chExt cx="2940457" cy="512718"/>
+          </a:xfrm>
+        </p:grpSpPr>
+        <p:cxnSp>
+          <p:nvCxnSpPr>
+            <p:cNvPr id="34" name="Connecteur droit avec flèche 33">
+              <a:extLst>
+                <a:ext uri="{FF2B5EF4-FFF2-40B4-BE49-F238E27FC236}">
+                  <a16:creationId xmlns:a16="http://schemas.microsoft.com/office/drawing/2014/main" id="{94782644-0E00-7B5F-9DB7-E712CAF930D6}"/>
+                </a:ext>
+              </a:extLst>
+            </p:cNvPr>
+            <p:cNvCxnSpPr>
+              <a:cxnSpLocks/>
+            </p:cNvCxnSpPr>
+            <p:nvPr/>
+          </p:nvCxnSpPr>
+          <p:spPr>
+            <a:xfrm>
+              <a:off x="6598733" y="2128152"/>
+              <a:ext cx="1209190" cy="257314"/>
+            </a:xfrm>
+            <a:prstGeom prst="straightConnector1">
+              <a:avLst/>
+            </a:prstGeom>
+            <a:ln>
+              <a:tailEnd type="triangle"/>
+            </a:ln>
+          </p:spPr>
+          <p:style>
+            <a:lnRef idx="2">
+              <a:schemeClr val="dk1"/>
+            </a:lnRef>
+            <a:fillRef idx="0">
+              <a:schemeClr val="dk1"/>
+            </a:fillRef>
+            <a:effectRef idx="1">
+              <a:schemeClr val="dk1"/>
+            </a:effectRef>
+            <a:fontRef idx="minor">
+              <a:schemeClr val="tx1"/>
+            </a:fontRef>
+          </p:style>
+        </p:cxnSp>
+        <p:sp>
+          <p:nvSpPr>
+            <p:cNvPr id="35" name="ZoneTexte 34">
+              <a:extLst>
+                <a:ext uri="{FF2B5EF4-FFF2-40B4-BE49-F238E27FC236}">
+                  <a16:creationId xmlns:a16="http://schemas.microsoft.com/office/drawing/2014/main" id="{2A78C0AE-5800-B122-5939-ECE9F8542E23}"/>
+                </a:ext>
+              </a:extLst>
+            </p:cNvPr>
+            <p:cNvSpPr txBox="1"/>
+            <p:nvPr/>
+          </p:nvSpPr>
+          <p:spPr>
+            <a:xfrm>
+              <a:off x="4867466" y="1872748"/>
+              <a:ext cx="1721946" cy="369332"/>
+            </a:xfrm>
+            <a:prstGeom prst="rect">
+              <a:avLst/>
+            </a:prstGeom>
+            <a:noFill/>
+          </p:spPr>
+          <p:txBody>
+            <a:bodyPr wrap="none" rtlCol="0">
+              <a:spAutoFit/>
+            </a:bodyPr>
+            <a:lstStyle/>
+            <a:p>
+              <a:r>
+                <a:rPr lang="fr-FR" dirty="0"/>
+                <a:t>Commun (</a:t>
+              </a:r>
+              <a:r>
+                <a:rPr lang="fr-FR" dirty="0" err="1"/>
+                <a:t>Gnd</a:t>
+              </a:r>
+              <a:r>
+                <a:rPr lang="fr-FR" dirty="0"/>
+                <a:t>)</a:t>
+              </a:r>
+            </a:p>
+          </p:txBody>
+        </p:sp>
+      </p:grpSp>
+      <p:grpSp>
+        <p:nvGrpSpPr>
+          <p:cNvPr id="38" name="Groupe 37">
+            <a:extLst>
+              <a:ext uri="{FF2B5EF4-FFF2-40B4-BE49-F238E27FC236}">
+                <a16:creationId xmlns:a16="http://schemas.microsoft.com/office/drawing/2014/main" id="{70378BAA-33B7-380A-0E97-1F21ABFCA58C}"/>
+              </a:ext>
+            </a:extLst>
+          </p:cNvPr>
+          <p:cNvGrpSpPr/>
+          <p:nvPr/>
+        </p:nvGrpSpPr>
+        <p:grpSpPr>
+          <a:xfrm>
+            <a:off x="1969498" y="1889202"/>
+            <a:ext cx="1054971" cy="1293847"/>
+            <a:chOff x="4572000" y="2290813"/>
+            <a:chExt cx="1054971" cy="1293847"/>
+          </a:xfrm>
+        </p:grpSpPr>
+        <p:cxnSp>
+          <p:nvCxnSpPr>
+            <p:cNvPr id="39" name="Connecteur droit avec flèche 38">
+              <a:extLst>
+                <a:ext uri="{FF2B5EF4-FFF2-40B4-BE49-F238E27FC236}">
+                  <a16:creationId xmlns:a16="http://schemas.microsoft.com/office/drawing/2014/main" id="{86EA1133-33C6-00DE-0B42-D57C8EACF9BB}"/>
+                </a:ext>
+              </a:extLst>
+            </p:cNvPr>
+            <p:cNvCxnSpPr>
+              <a:cxnSpLocks/>
+            </p:cNvCxnSpPr>
+            <p:nvPr/>
+          </p:nvCxnSpPr>
+          <p:spPr>
+            <a:xfrm flipH="1" flipV="1">
+              <a:off x="4572000" y="2290813"/>
+              <a:ext cx="298459" cy="882175"/>
+            </a:xfrm>
+            <a:prstGeom prst="straightConnector1">
+              <a:avLst/>
+            </a:prstGeom>
+            <a:ln>
+              <a:tailEnd type="triangle"/>
+            </a:ln>
+          </p:spPr>
+          <p:style>
+            <a:lnRef idx="2">
+              <a:schemeClr val="dk1"/>
+            </a:lnRef>
+            <a:fillRef idx="0">
+              <a:schemeClr val="dk1"/>
+            </a:fillRef>
+            <a:effectRef idx="1">
+              <a:schemeClr val="dk1"/>
+            </a:effectRef>
+            <a:fontRef idx="minor">
+              <a:schemeClr val="tx1"/>
+            </a:fontRef>
+          </p:style>
+        </p:cxnSp>
+        <p:sp>
+          <p:nvSpPr>
+            <p:cNvPr id="40" name="ZoneTexte 39">
+              <a:extLst>
+                <a:ext uri="{FF2B5EF4-FFF2-40B4-BE49-F238E27FC236}">
+                  <a16:creationId xmlns:a16="http://schemas.microsoft.com/office/drawing/2014/main" id="{0D0B4A67-6CE0-95C9-8A53-D0289FEAF83D}"/>
+                </a:ext>
+              </a:extLst>
+            </p:cNvPr>
+            <p:cNvSpPr txBox="1"/>
+            <p:nvPr/>
+          </p:nvSpPr>
+          <p:spPr>
+            <a:xfrm>
+              <a:off x="4599126" y="3215328"/>
+              <a:ext cx="1027845" cy="369332"/>
+            </a:xfrm>
+            <a:prstGeom prst="rect">
+              <a:avLst/>
+            </a:prstGeom>
+            <a:noFill/>
+          </p:spPr>
+          <p:txBody>
+            <a:bodyPr wrap="none" rtlCol="0">
+              <a:spAutoFit/>
+            </a:bodyPr>
+            <a:lstStyle/>
+            <a:p>
+              <a:r>
+                <a:rPr lang="fr-FR" dirty="0"/>
+                <a:t>Bas (N1)</a:t>
+              </a:r>
+            </a:p>
+          </p:txBody>
+        </p:sp>
+      </p:grpSp>
+      <p:grpSp>
+        <p:nvGrpSpPr>
+          <p:cNvPr id="47" name="Groupe 46">
+            <a:extLst>
+              <a:ext uri="{FF2B5EF4-FFF2-40B4-BE49-F238E27FC236}">
+                <a16:creationId xmlns:a16="http://schemas.microsoft.com/office/drawing/2014/main" id="{D335A3C4-4B60-C4E9-5FC7-A8CB0395516A}"/>
+              </a:ext>
+            </a:extLst>
+          </p:cNvPr>
+          <p:cNvGrpSpPr/>
+          <p:nvPr/>
+        </p:nvGrpSpPr>
+        <p:grpSpPr>
+          <a:xfrm>
+            <a:off x="1534982" y="5113062"/>
+            <a:ext cx="2835388" cy="518966"/>
+            <a:chOff x="6678663" y="719544"/>
+            <a:chExt cx="2835388" cy="518966"/>
+          </a:xfrm>
+        </p:grpSpPr>
+        <p:cxnSp>
+          <p:nvCxnSpPr>
+            <p:cNvPr id="48" name="Connecteur droit avec flèche 47">
+              <a:extLst>
+                <a:ext uri="{FF2B5EF4-FFF2-40B4-BE49-F238E27FC236}">
+                  <a16:creationId xmlns:a16="http://schemas.microsoft.com/office/drawing/2014/main" id="{661DB2D8-A54A-0B0E-0E10-90007C90541B}"/>
+                </a:ext>
+              </a:extLst>
+            </p:cNvPr>
+            <p:cNvCxnSpPr>
+              <a:cxnSpLocks/>
+            </p:cNvCxnSpPr>
+            <p:nvPr/>
+          </p:nvCxnSpPr>
+          <p:spPr>
+            <a:xfrm flipV="1">
+              <a:off x="7970224" y="719544"/>
+              <a:ext cx="1543827" cy="388358"/>
+            </a:xfrm>
+            <a:prstGeom prst="straightConnector1">
+              <a:avLst/>
+            </a:prstGeom>
+            <a:ln>
+              <a:tailEnd type="triangle"/>
+            </a:ln>
+          </p:spPr>
+          <p:style>
+            <a:lnRef idx="2">
+              <a:schemeClr val="dk1"/>
+            </a:lnRef>
+            <a:fillRef idx="0">
+              <a:schemeClr val="dk1"/>
+            </a:fillRef>
+            <a:effectRef idx="1">
+              <a:schemeClr val="dk1"/>
+            </a:effectRef>
+            <a:fontRef idx="minor">
+              <a:schemeClr val="tx1"/>
+            </a:fontRef>
+          </p:style>
+        </p:cxnSp>
+        <p:sp>
+          <p:nvSpPr>
+            <p:cNvPr id="49" name="ZoneTexte 48">
+              <a:extLst>
+                <a:ext uri="{FF2B5EF4-FFF2-40B4-BE49-F238E27FC236}">
+                  <a16:creationId xmlns:a16="http://schemas.microsoft.com/office/drawing/2014/main" id="{79D44A23-D775-0F9A-13D0-707F2E286A07}"/>
+                </a:ext>
+              </a:extLst>
+            </p:cNvPr>
+            <p:cNvSpPr txBox="1"/>
+            <p:nvPr/>
+          </p:nvSpPr>
+          <p:spPr>
+            <a:xfrm>
+              <a:off x="6678663" y="869178"/>
+              <a:ext cx="1253869" cy="369332"/>
+            </a:xfrm>
+            <a:prstGeom prst="rect">
+              <a:avLst/>
+            </a:prstGeom>
+            <a:noFill/>
+          </p:spPr>
+          <p:txBody>
+            <a:bodyPr wrap="none" rtlCol="0">
+              <a:spAutoFit/>
+            </a:bodyPr>
+            <a:lstStyle/>
+            <a:p>
+              <a:r>
+                <a:rPr lang="fr-FR" dirty="0"/>
+                <a:t>Milieu (N2)</a:t>
+              </a:r>
+            </a:p>
+          </p:txBody>
+        </p:sp>
+      </p:grpSp>
+      <p:grpSp>
+        <p:nvGrpSpPr>
+          <p:cNvPr id="53" name="Groupe 52">
+            <a:extLst>
+              <a:ext uri="{FF2B5EF4-FFF2-40B4-BE49-F238E27FC236}">
+                <a16:creationId xmlns:a16="http://schemas.microsoft.com/office/drawing/2014/main" id="{07EC6D20-0FBC-E335-13A2-05269BCF2D41}"/>
+              </a:ext>
+            </a:extLst>
+          </p:cNvPr>
+          <p:cNvGrpSpPr/>
+          <p:nvPr/>
+        </p:nvGrpSpPr>
+        <p:grpSpPr>
+          <a:xfrm>
+            <a:off x="1736908" y="5262696"/>
+            <a:ext cx="2891103" cy="864129"/>
+            <a:chOff x="3156859" y="-73388"/>
+            <a:chExt cx="2891103" cy="864129"/>
+          </a:xfrm>
+        </p:grpSpPr>
+        <p:cxnSp>
+          <p:nvCxnSpPr>
+            <p:cNvPr id="54" name="Connecteur droit avec flèche 53">
+              <a:extLst>
+                <a:ext uri="{FF2B5EF4-FFF2-40B4-BE49-F238E27FC236}">
+                  <a16:creationId xmlns:a16="http://schemas.microsoft.com/office/drawing/2014/main" id="{44973CE4-96A0-1F47-E799-EECBA4D2E528}"/>
+                </a:ext>
+              </a:extLst>
+            </p:cNvPr>
+            <p:cNvCxnSpPr>
+              <a:cxnSpLocks/>
+            </p:cNvCxnSpPr>
+            <p:nvPr/>
+          </p:nvCxnSpPr>
+          <p:spPr>
+            <a:xfrm flipV="1">
+              <a:off x="4355278" y="-73388"/>
+              <a:ext cx="1692684" cy="679463"/>
+            </a:xfrm>
+            <a:prstGeom prst="straightConnector1">
+              <a:avLst/>
+            </a:prstGeom>
+            <a:ln>
+              <a:tailEnd type="triangle"/>
+            </a:ln>
+          </p:spPr>
+          <p:style>
+            <a:lnRef idx="2">
+              <a:schemeClr val="dk1"/>
+            </a:lnRef>
+            <a:fillRef idx="0">
+              <a:schemeClr val="dk1"/>
+            </a:fillRef>
+            <a:effectRef idx="1">
+              <a:schemeClr val="dk1"/>
+            </a:effectRef>
+            <a:fontRef idx="minor">
+              <a:schemeClr val="tx1"/>
+            </a:fontRef>
+          </p:style>
+        </p:cxnSp>
+        <p:sp>
+          <p:nvSpPr>
+            <p:cNvPr id="55" name="ZoneTexte 54">
+              <a:extLst>
+                <a:ext uri="{FF2B5EF4-FFF2-40B4-BE49-F238E27FC236}">
+                  <a16:creationId xmlns:a16="http://schemas.microsoft.com/office/drawing/2014/main" id="{5463BEE5-8216-4B2E-FB41-D8F9054A3088}"/>
+                </a:ext>
+              </a:extLst>
+            </p:cNvPr>
+            <p:cNvSpPr txBox="1"/>
+            <p:nvPr/>
+          </p:nvSpPr>
+          <p:spPr>
+            <a:xfrm>
+              <a:off x="3156859" y="421409"/>
+              <a:ext cx="1143262" cy="369332"/>
+            </a:xfrm>
+            <a:prstGeom prst="rect">
+              <a:avLst/>
+            </a:prstGeom>
+            <a:noFill/>
+          </p:spPr>
+          <p:txBody>
+            <a:bodyPr wrap="none" rtlCol="0">
+              <a:spAutoFit/>
+            </a:bodyPr>
+            <a:lstStyle/>
+            <a:p>
+              <a:r>
+                <a:rPr lang="fr-FR" dirty="0"/>
+                <a:t>Haut (N3)</a:t>
+              </a:r>
+            </a:p>
+          </p:txBody>
+        </p:sp>
+      </p:grpSp>
+      <p:sp>
+        <p:nvSpPr>
+          <p:cNvPr id="58" name="ZoneTexte 57">
+            <a:extLst>
+              <a:ext uri="{FF2B5EF4-FFF2-40B4-BE49-F238E27FC236}">
+                <a16:creationId xmlns:a16="http://schemas.microsoft.com/office/drawing/2014/main" id="{EF5931AA-7EFD-0C63-CD10-E23EACB2826B}"/>
+              </a:ext>
+            </a:extLst>
+          </p:cNvPr>
+          <p:cNvSpPr txBox="1"/>
+          <p:nvPr/>
+        </p:nvSpPr>
+        <p:spPr>
+          <a:xfrm>
+            <a:off x="3937206" y="5671351"/>
+            <a:ext cx="1320490" cy="369332"/>
+          </a:xfrm>
+          <a:prstGeom prst="rect">
+            <a:avLst/>
+          </a:prstGeom>
+          <a:noFill/>
+        </p:spPr>
+        <p:txBody>
+          <a:bodyPr wrap="none" rtlCol="0">
+            <a:spAutoFit/>
+          </a:bodyPr>
+          <a:lstStyle/>
+          <a:p>
+            <a:r>
+              <a:rPr lang="fr-FR" b="1" dirty="0"/>
+              <a:t>Côté Carte</a:t>
             </a:r>
           </a:p>
         </p:txBody>

</xml_diff>